<commit_message>
Regenerate Day 1 decks after Part B rework
Deck content had already been updated in scripts/build-decks/day1.js
but the .pptx files weren't regenerated in the previous commit
because node wasn't on PATH.

Co-authored-by: Copilot <223556219+Copilot@users.noreply.github.com>
</commit_message>
<xml_diff>
--- a/decks/day1/module-6-hosting-options.pptx
+++ b/decks/day1/module-6-hosting-options.pptx
@@ -796,7 +796,7 @@
               <a:t>• Bridge to Module 7 (lab kickoff)
 • Three parts map 1:1 to the three paths just covered
 • Part A: Prompt agent (~30 min)
-• Part B: Hosted agent — connect to pre-deployed (~30 min)
+• Part B: Hosted agent — deploy your own with azd (~45 min)
 • Part C: your code + Responses API — the meaty coding part (~45 min)
 • Stretch: zip your Part C code and deploy as your own Hosted agent
 • Attendees should feel prepared, not overwhelmed</a:t>
@@ -3407,7 +3407,7 @@
                 <a:ea typeface="Calibri" pitchFamily="34" charset="-122"/>
                 <a:cs typeface="Calibri" pitchFamily="34" charset="-120"/>
               </a:rPr>
-              <a:t>Part B — Hosted agent: connect to a pre-deployed Hosted agent in the sandbox; walk the portal to see what Foundry manages (endpoint, tracing, identity, Toolbox tool, content safety)</a:t>
+              <a:t>Part B — Hosted agent: deploy your own Hosted agent with azd; connect to it and walk the portal to see what Foundry manages (endpoint, tracing, dedicated identity, content safety)</a:t>
             </a:r>
             <a:endParaRPr lang="en-US" sz="1400" dirty="0"/>
           </a:p>
@@ -3449,7 +3449,7 @@
                 <a:ea typeface="Calibri" pitchFamily="34" charset="-122"/>
                 <a:cs typeface="Calibri" pitchFamily="34" charset="-120"/>
               </a:rPr>
-              <a:t>Stretch (Part C): zip your Part C code and deploy it as your own Hosted agent</a:t>
+              <a:t>Stretch (Part C): extend your Part C code with a custom function tool or a Foundry IQ knowledge source (both deep-dive on Days 2–3)</a:t>
             </a:r>
             <a:endParaRPr lang="en-US" sz="1400" dirty="0"/>
           </a:p>

</xml_diff>